<commit_message>
Set author name, stop tracking node_modules, re-verify 14 unit and 38 e2e tests
Co-Authored-By: Claude Sonnet 5.5 <noreply@anthropic.com>
Claude-Session: https://claude.ai/code/session_016KZaRNAsEycNYHuGW6T7gR
</commit_message>
<xml_diff>
--- a/docs/presentation/presentation.pptx
+++ b/docs/presentation/presentation.pptx
@@ -2490,7 +2490,7 @@
                   <a:schemeClr val="accent5"/>
                 </a:solidFill>
               </a:rPr>
-              <a:t>Archana Jangamgunta · October 2026</a:t>
+              <a:t>Eswara Krishna Bodi · October 2026</a:t>
             </a:r>
             <a:endParaRPr lang="en-US" sz="1600" dirty="0"/>
           </a:p>
@@ -2961,6 +2961,10 @@
             <a:prstDash val="solid"/>
           </a:ln>
         </p:spPr>
+        <p:txBody>
+          <a:bodyPr/>
+          <a:p/>
+        </p:txBody>
       </p:sp>
       <p:sp>
         <p:nvSpPr>
@@ -3094,6 +3098,10 @@
             <a:prstDash val="solid"/>
           </a:ln>
         </p:spPr>
+        <p:txBody>
+          <a:bodyPr/>
+          <a:p/>
+        </p:txBody>
       </p:sp>
       <p:sp>
         <p:nvSpPr>
@@ -3227,6 +3235,10 @@
             <a:prstDash val="solid"/>
           </a:ln>
         </p:spPr>
+        <p:txBody>
+          <a:bodyPr/>
+          <a:p/>
+        </p:txBody>
       </p:sp>
       <p:sp>
         <p:nvSpPr>
@@ -3360,6 +3372,10 @@
             <a:prstDash val="solid"/>
           </a:ln>
         </p:spPr>
+        <p:txBody>
+          <a:bodyPr/>
+          <a:p/>
+        </p:txBody>
       </p:sp>
       <p:sp>
         <p:nvSpPr>
@@ -3493,6 +3509,10 @@
             <a:prstDash val="solid"/>
           </a:ln>
         </p:spPr>
+        <p:txBody>
+          <a:bodyPr/>
+          <a:p/>
+        </p:txBody>
       </p:sp>
       <p:sp>
         <p:nvSpPr>
@@ -4037,6 +4057,10 @@
             <a:prstDash val="solid"/>
           </a:ln>
         </p:spPr>
+        <p:txBody>
+          <a:bodyPr/>
+          <a:p/>
+        </p:txBody>
       </p:sp>
       <p:sp>
         <p:nvSpPr>
@@ -4062,6 +4086,10 @@
             <a:prstDash val="solid"/>
           </a:ln>
         </p:spPr>
+        <p:txBody>
+          <a:bodyPr/>
+          <a:p/>
+        </p:txBody>
       </p:sp>
       <p:sp>
         <p:nvSpPr>
@@ -4159,6 +4187,10 @@
             <a:prstDash val="solid"/>
           </a:ln>
         </p:spPr>
+        <p:txBody>
+          <a:bodyPr/>
+          <a:p/>
+        </p:txBody>
       </p:sp>
       <p:sp>
         <p:nvSpPr>
@@ -4184,6 +4216,10 @@
             <a:prstDash val="solid"/>
           </a:ln>
         </p:spPr>
+        <p:txBody>
+          <a:bodyPr/>
+          <a:p/>
+        </p:txBody>
       </p:sp>
       <p:sp>
         <p:nvSpPr>
@@ -4281,6 +4317,10 @@
             <a:prstDash val="solid"/>
           </a:ln>
         </p:spPr>
+        <p:txBody>
+          <a:bodyPr/>
+          <a:p/>
+        </p:txBody>
       </p:sp>
       <p:sp>
         <p:nvSpPr>
@@ -4306,6 +4346,10 @@
             <a:prstDash val="solid"/>
           </a:ln>
         </p:spPr>
+        <p:txBody>
+          <a:bodyPr/>
+          <a:p/>
+        </p:txBody>
       </p:sp>
       <p:sp>
         <p:nvSpPr>
@@ -4512,6 +4556,10 @@
             <a:prstDash val="solid"/>
           </a:ln>
         </p:spPr>
+        <p:txBody>
+          <a:bodyPr/>
+          <a:p/>
+        </p:txBody>
       </p:sp>
       <p:sp>
         <p:nvSpPr>
@@ -4645,6 +4693,10 @@
             <a:prstDash val="solid"/>
           </a:ln>
         </p:spPr>
+        <p:txBody>
+          <a:bodyPr/>
+          <a:p/>
+        </p:txBody>
       </p:sp>
       <p:sp>
         <p:nvSpPr>
@@ -4778,6 +4830,10 @@
             <a:prstDash val="solid"/>
           </a:ln>
         </p:spPr>
+        <p:txBody>
+          <a:bodyPr/>
+          <a:p/>
+        </p:txBody>
       </p:sp>
       <p:sp>
         <p:nvSpPr>
@@ -4911,6 +4967,10 @@
             <a:prstDash val="solid"/>
           </a:ln>
         </p:spPr>
+        <p:txBody>
+          <a:bodyPr/>
+          <a:p/>
+        </p:txBody>
       </p:sp>
       <p:sp>
         <p:nvSpPr>
@@ -5044,6 +5104,10 @@
             <a:prstDash val="solid"/>
           </a:ln>
         </p:spPr>
+        <p:txBody>
+          <a:bodyPr/>
+          <a:p/>
+        </p:txBody>
       </p:sp>
       <p:sp>
         <p:nvSpPr>
@@ -5177,6 +5241,10 @@
             <a:prstDash val="solid"/>
           </a:ln>
         </p:spPr>
+        <p:txBody>
+          <a:bodyPr/>
+          <a:p/>
+        </p:txBody>
       </p:sp>
       <p:sp>
         <p:nvSpPr>
@@ -5419,6 +5487,10 @@
             <a:prstDash val="solid"/>
           </a:ln>
         </p:spPr>
+        <p:txBody>
+          <a:bodyPr/>
+          <a:p/>
+        </p:txBody>
       </p:sp>
       <p:sp>
         <p:nvSpPr>
@@ -5552,6 +5624,10 @@
             <a:prstDash val="solid"/>
           </a:ln>
         </p:spPr>
+        <p:txBody>
+          <a:bodyPr/>
+          <a:p/>
+        </p:txBody>
       </p:sp>
       <p:sp>
         <p:nvSpPr>
@@ -5685,6 +5761,10 @@
             <a:prstDash val="solid"/>
           </a:ln>
         </p:spPr>
+        <p:txBody>
+          <a:bodyPr/>
+          <a:p/>
+        </p:txBody>
       </p:sp>
       <p:sp>
         <p:nvSpPr>
@@ -5782,6 +5862,10 @@
             <a:prstDash val="solid"/>
           </a:ln>
         </p:spPr>
+        <p:txBody>
+          <a:bodyPr/>
+          <a:p/>
+        </p:txBody>
       </p:sp>
       <p:sp>
         <p:nvSpPr>
@@ -7889,6 +7973,10 @@
             <a:prstDash val="solid"/>
           </a:ln>
         </p:spPr>
+        <p:txBody>
+          <a:bodyPr/>
+          <a:p/>
+        </p:txBody>
       </p:sp>
       <p:sp>
         <p:nvSpPr>
@@ -8007,6 +8095,10 @@
             <a:prstDash val="solid"/>
           </a:ln>
         </p:spPr>
+        <p:txBody>
+          <a:bodyPr/>
+          <a:p/>
+        </p:txBody>
       </p:sp>
       <p:sp>
         <p:nvSpPr>
@@ -8125,6 +8217,10 @@
             <a:prstDash val="solid"/>
           </a:ln>
         </p:spPr>
+        <p:txBody>
+          <a:bodyPr/>
+          <a:p/>
+        </p:txBody>
       </p:sp>
       <p:sp>
         <p:nvSpPr>
@@ -8243,6 +8339,10 @@
             <a:prstDash val="solid"/>
           </a:ln>
         </p:spPr>
+        <p:txBody>
+          <a:bodyPr/>
+          <a:p/>
+        </p:txBody>
       </p:sp>
       <p:sp>
         <p:nvSpPr>
@@ -8506,6 +8606,10 @@
             <a:prstDash val="solid"/>
           </a:ln>
         </p:spPr>
+        <p:txBody>
+          <a:bodyPr/>
+          <a:p/>
+        </p:txBody>
       </p:sp>
       <p:sp>
         <p:nvSpPr>
@@ -8624,6 +8728,10 @@
             <a:prstDash val="solid"/>
           </a:ln>
         </p:spPr>
+        <p:txBody>
+          <a:bodyPr/>
+          <a:p/>
+        </p:txBody>
       </p:sp>
       <p:sp>
         <p:nvSpPr>
@@ -8830,6 +8938,10 @@
             <a:prstDash val="solid"/>
           </a:ln>
         </p:spPr>
+        <p:txBody>
+          <a:bodyPr/>
+          <a:p/>
+        </p:txBody>
       </p:sp>
       <p:sp>
         <p:nvSpPr>
@@ -8927,6 +9039,10 @@
             <a:prstDash val="solid"/>
           </a:ln>
         </p:spPr>
+        <p:txBody>
+          <a:bodyPr/>
+          <a:p/>
+        </p:txBody>
       </p:sp>
       <p:sp>
         <p:nvSpPr>
@@ -9024,6 +9140,10 @@
             <a:prstDash val="solid"/>
           </a:ln>
         </p:spPr>
+        <p:txBody>
+          <a:bodyPr/>
+          <a:p/>
+        </p:txBody>
       </p:sp>
       <p:sp>
         <p:nvSpPr>
@@ -9121,6 +9241,10 @@
             <a:prstDash val="solid"/>
           </a:ln>
         </p:spPr>
+        <p:txBody>
+          <a:bodyPr/>
+          <a:p/>
+        </p:txBody>
       </p:sp>
       <p:sp>
         <p:nvSpPr>
@@ -9218,6 +9342,10 @@
             <a:prstDash val="solid"/>
           </a:ln>
         </p:spPr>
+        <p:txBody>
+          <a:bodyPr/>
+          <a:p/>
+        </p:txBody>
       </p:sp>
       <p:sp>
         <p:nvSpPr>

</xml_diff>